<commit_message>
jury: de-AI copy pass — category badges, 10-class select tip
Tighten slogans, fix close-page garbled thanks, align Na/Au/Og as category reps.
</commit_message>
<xml_diff>
--- a/docs/jury/stardust-jury.pptx
+++ b/docs/jury/stardust-jury.pptx
@@ -1599,7 +1599,7 @@
                 <a:ea typeface="Noto Sans CJK SC" pitchFamily="34" charset="-122"/>
                 <a:cs typeface="Noto Sans CJK SC" pitchFamily="34" charset="-120"/>
               </a:rPr>
-              <a:t>一张可以核对的元素周期表</a:t>
+              <a:t>一张能核对来源的周期表</a:t>
             </a:r>
             <a:endParaRPr lang="en-US" sz="2200" dirty="0"/>
           </a:p>
@@ -1809,7 +1809,7 @@
                 <a:ea typeface="Noto Sans CJK SC" pitchFamily="34" charset="-122"/>
                 <a:cs typeface="Noto Sans CJK SC" pitchFamily="34" charset="-120"/>
               </a:rPr>
-              <a:t>留空不假造</a:t>
+              <a:t>无则留空</a:t>
             </a:r>
             <a:endParaRPr lang="en-US" sz="1600" dirty="0"/>
           </a:p>
@@ -1929,6 +1929,42 @@
               <a:t>01  /  08</a:t>
             </a:r>
             <a:endParaRPr lang="en-US" sz="1100" dirty="0"/>
+          </a:p>
+        </p:txBody>
+      </p:sp>
+      <p:sp>
+        <p:nvSpPr>
+          <p:cNvPr id="14" name="TextBox 13"/>
+          <p:cNvSpPr txBox="1"/>
+          <p:nvPr/>
+        </p:nvSpPr>
+        <p:spPr>
+          <a:xfrm>
+            <a:off x="822960" y="5349240"/>
+            <a:ext cx="10515600" cy="320040"/>
+          </a:xfrm>
+          <a:prstGeom prst="rect">
+            <a:avLst/>
+          </a:prstGeom>
+          <a:noFill/>
+        </p:spPr>
+        <p:txBody>
+          <a:bodyPr wrap="square">
+            <a:spAutoFit/>
+          </a:bodyPr>
+          <a:lstStyle/>
+          <a:p>
+            <a:pPr algn="l"/>
+            <a:r>
+              <a:rPr sz="1300">
+                <a:solidFill>
+                  <a:srgbClr val="8A8680"/>
+                </a:solidFill>
+                <a:latin typeface="Noto Sans CJK SC"/>
+                <a:ea typeface="Noto Sans CJK SC"/>
+              </a:rPr>
+              <a:t>Na 碱金属 · Au 过渡 · Og 稀有气体</a:t>
+            </a:r>
           </a:p>
         </p:txBody>
       </p:sp>
@@ -2044,7 +2080,7 @@
         <p:spPr>
           <a:xfrm>
             <a:off x="822960" y="2148840"/>
-            <a:ext cx="10515600" cy="1828800"/>
+            <a:ext cx="10515600" cy="822960"/>
           </a:xfrm>
           <a:prstGeom prst="rect">
             <a:avLst/>
@@ -2068,63 +2104,46 @@
                 <a:ea typeface="Noto Serif CJK SC" pitchFamily="34" charset="-122"/>
                 <a:cs typeface="Noto Serif CJK SC" pitchFamily="34" charset="-120"/>
               </a:rPr>
-              <a:t>裁判为什么该信</a:t>
+              <a:t>凭什么信这张表</a:t>
             </a:r>
             <a:endParaRPr lang="en-US" sz="4400" dirty="0"/>
           </a:p>
+        </p:txBody>
+      </p:sp>
+      <p:sp>
+        <p:nvSpPr>
+          <p:cNvPr id="5" name="Text 3"/>
+          <p:cNvSpPr/>
+          <p:nvPr/>
+        </p:nvSpPr>
+        <p:spPr>
+          <a:xfrm>
+            <a:off x="822960" y="4297680"/>
+            <a:ext cx="10515600" cy="548640"/>
+          </a:xfrm>
+          <a:prstGeom prst="rect">
+            <a:avLst/>
+          </a:prstGeom>
+          <a:noFill/>
+          <a:ln/>
+        </p:spPr>
+        <p:txBody>
+          <a:bodyPr wrap="square" lIns="0" tIns="0" rIns="0" bIns="0" rtlCol="0" anchor="ctr"/>
+          <a:lstStyle/>
           <a:p>
             <a:pPr indent="0" marL="0">
               <a:buNone/>
             </a:pPr>
             <a:r>
-              <a:rPr lang="en-US" sz="4400" b="1" spc="200" kern="0" dirty="0">
-                <a:solidFill>
-                  <a:srgbClr val="F2EFE6"/>
+              <a:rPr lang="en-US" sz="2800" dirty="0">
+                <a:solidFill>
+                  <a:srgbClr val="C9A84C"/>
                 </a:solidFill>
                 <a:latin typeface="Noto Serif CJK SC" pitchFamily="34" charset="0"/>
                 <a:ea typeface="Noto Serif CJK SC" pitchFamily="34" charset="-122"/>
                 <a:cs typeface="Noto Serif CJK SC" pitchFamily="34" charset="-120"/>
               </a:rPr>
-              <a:t>一张网页周期表？</a:t>
-            </a:r>
-            <a:endParaRPr lang="en-US" sz="4400" dirty="0"/>
-          </a:p>
-        </p:txBody>
-      </p:sp>
-      <p:sp>
-        <p:nvSpPr>
-          <p:cNvPr id="5" name="Text 3"/>
-          <p:cNvSpPr/>
-          <p:nvPr/>
-        </p:nvSpPr>
-        <p:spPr>
-          <a:xfrm>
-            <a:off x="822960" y="4297680"/>
-            <a:ext cx="10515600" cy="548640"/>
-          </a:xfrm>
-          <a:prstGeom prst="rect">
-            <a:avLst/>
-          </a:prstGeom>
-          <a:noFill/>
-          <a:ln/>
-        </p:spPr>
-        <p:txBody>
-          <a:bodyPr wrap="square" lIns="0" tIns="0" rIns="0" bIns="0" rtlCol="0" anchor="ctr"/>
-          <a:lstStyle/>
-          <a:p>
-            <a:pPr indent="0" marL="0">
-              <a:buNone/>
-            </a:pPr>
-            <a:r>
-              <a:rPr lang="en-US" sz="2800" dirty="0">
-                <a:solidFill>
-                  <a:srgbClr val="C9A84C"/>
-                </a:solidFill>
-                <a:latin typeface="Noto Serif CJK SC" pitchFamily="34" charset="0"/>
-                <a:ea typeface="Noto Serif CJK SC" pitchFamily="34" charset="-122"/>
-                <a:cs typeface="Noto Serif CJK SC" pitchFamily="34" charset="-120"/>
-              </a:rPr>
-              <a:t>可核对、不编造。</a:t>
+              <a:t>来源写得出，没有就不写。</a:t>
             </a:r>
             <a:endParaRPr lang="en-US" sz="2800" dirty="0"/>
           </a:p>
@@ -2635,7 +2654,7 @@
                 <a:ea typeface="Noto Sans CJK SC" pitchFamily="34" charset="-122"/>
                 <a:cs typeface="Noto Sans CJK SC" pitchFamily="34" charset="-120"/>
               </a:rPr>
-              <a:t>节选自强线表</a:t>
+              <a:t>可见线摘自强线表</a:t>
             </a:r>
             <a:endParaRPr lang="en-US" sz="1600" dirty="0"/>
           </a:p>
@@ -2800,7 +2819,7 @@
                 <a:ea typeface="Noto Sans CJK SC" pitchFamily="34" charset="-122"/>
                 <a:cs typeface="Noto Sans CJK SC" pitchFamily="34" charset="-120"/>
               </a:rPr>
-              <a:t>不要编数字</a:t>
+              <a:t>查不到就不填</a:t>
             </a:r>
             <a:endParaRPr lang="en-US" sz="1600" dirty="0"/>
           </a:p>
@@ -4016,7 +4035,7 @@
                 <a:ea typeface="Noto Sans CJK SC" pitchFamily="34" charset="-122"/>
                 <a:cs typeface="Noto Sans CJK SC" pitchFamily="34" charset="-120"/>
               </a:rPr>
-              <a:t>可核对，不是神话卡</a:t>
+              <a:t>仍可查谱线</a:t>
             </a:r>
             <a:endParaRPr lang="en-US" sz="1600" dirty="0"/>
           </a:p>
@@ -4129,7 +4148,7 @@
                 <a:ea typeface="Noto Sans CJK SC" pitchFamily="34" charset="-122"/>
                 <a:cs typeface="Noto Sans CJK SC" pitchFamily="34" charset="-120"/>
               </a:rPr>
-              <a:t>对照  ·  诚实留空</a:t>
+              <a:t>对照  ·  留空</a:t>
             </a:r>
             <a:endParaRPr lang="en-US" sz="1400" dirty="0"/>
           </a:p>
@@ -4493,7 +4512,7 @@
                 <a:ea typeface="Noto Serif CJK SC" pitchFamily="34" charset="-122"/>
                 <a:cs typeface="Noto Serif CJK SC" pitchFamily="34" charset="-120"/>
               </a:rPr>
-              <a:t>科学分来自空白，不是特效。</a:t>
+              <a:t>没有就空着。</a:t>
             </a:r>
             <a:endParaRPr lang="en-US" sz="2000" dirty="0"/>
           </a:p>
@@ -5556,7 +5575,7 @@
               <a:buNone/>
             </a:pPr>
             <a:r>
-              <a:rPr lang="en-US" sz="7200" b="1" spc="1200" kern="0" dirty="0">
+              <a:rPr lang="zh-CN" sz="7200" b="1" spc="600" kern="0" dirty="0">
                 <a:solidFill>
                   <a:srgbClr val="C9A84C"/>
                 </a:solidFill>
@@ -5564,7 +5583,7 @@
                 <a:ea typeface="Noto Serif CJK SC" pitchFamily="34" charset="-122"/>
                 <a:cs typeface="Noto Serif CJK SC" pitchFamily="34" charset="-120"/>
               </a:rPr>
-              <a:t>可核对</a:t>
+              <a:t>核对入口</a:t>
             </a:r>
             <a:endParaRPr lang="en-US" sz="7200" dirty="0"/>
           </a:p>
@@ -5650,13 +5669,52 @@
       </p:sp>
       <p:sp>
         <p:nvSpPr>
+          <p:cNvPr id="8" name="Text tip"/>
+          <p:cNvSpPr/>
+          <p:nvPr/>
+        </p:nvSpPr>
+        <p:spPr>
+          <a:xfrm>
+            <a:off x="822960" y="4526280"/>
+            <a:ext cx="10515600" cy="365760"/>
+          </a:xfrm>
+          <a:prstGeom prst="rect">
+            <a:avLst/>
+          </a:prstGeom>
+          <a:noFill/>
+          <a:ln/>
+        </p:spPr>
+        <p:txBody>
+          <a:bodyPr wrap="square" lIns="0" tIns="0" rIns="0" bIns="0" rtlCol="0" anchor="ctr"/>
+          <a:lstStyle/>
+          <a:p>
+            <a:pPr algn="ctr" indent="0" marL="0">
+              <a:buNone/>
+            </a:pPr>
+            <a:r>
+              <a:rPr lang="zh-CN" sz="1400" dirty="0">
+                <a:solidFill>
+                  <a:srgbClr val="8A8680"/>
+                </a:solidFill>
+                <a:latin typeface="Noto Sans CJK SC" pitchFamily="34" charset="0"/>
+                <a:ea typeface="Noto Sans CJK SC" pitchFamily="34" charset="-122"/>
+                <a:cs typeface="Noto Sans CJK SC" pitchFamily="34" charset="-120"/>
+              </a:rPr>
+              <a:t>点选：同族同声，共 10 类</a:t>
+            </a:r>
+            <a:endParaRPr lang="en-US" sz="1500" dirty="0"/>
+          </a:p>
+        </p:txBody>
+      </p:sp>
+      <p:sp>
+        <p:nvSpPr>
           <p:cNvPr id="6" name="Text 4"/>
           <p:cNvSpPr/>
           <p:nvPr/>
         </p:nvSpPr>
         <p:spPr>
           <a:xfrm>
-            <a:off x="822960" y="4937760"/>
+            <a:off x="822960" y="5074920"/>
             <a:ext cx="10515600" cy="502920"/>
           </a:xfrm>
           <a:prstGeom prst="rect">
@@ -5673,7 +5731,7 @@
               <a:buNone/>
             </a:pPr>
             <a:r>
-              <a:rPr lang="en-US" sz="2800" dirty="0">
+              <a:rPr lang="zh-CN" sz="2800" dirty="0">
                 <a:solidFill>
                   <a:srgbClr val="F2EFE6"/>
                 </a:solidFill>

</xml_diff>